<commit_message>
Fixed the grammar in some slides.
</commit_message>
<xml_diff>
--- a/IOT technical.pptx
+++ b/IOT technical.pptx
@@ -6201,32 +6201,8 @@
         <a:lstStyle/>
         <a:p>
           <a:r>
-            <a:rPr lang="it-IT"/>
-            <a:t>To exit from the alert state, </a:t>
-          </a:r>
-          <a:r>
-            <a:rPr lang="it-IT" err="1"/>
-            <a:t>accesible</a:t>
-          </a:r>
-          <a:r>
-            <a:rPr lang="it-IT"/>
-            <a:t> </a:t>
-          </a:r>
-          <a:r>
-            <a:rPr lang="it-IT" err="1"/>
-            <a:t>only</a:t>
-          </a:r>
-          <a:r>
-            <a:rPr lang="it-IT"/>
-            <a:t> to </a:t>
-          </a:r>
-          <a:r>
-            <a:rPr lang="it-IT" err="1"/>
-            <a:t>personell</a:t>
-          </a:r>
-          <a:r>
-            <a:rPr lang="it-IT"/>
-            <a:t> </a:t>
+            <a:rPr lang="en-US" noProof="0" dirty="0"/>
+            <a:t>To exit from the alert state, accessible only to the personnel </a:t>
           </a:r>
         </a:p>
       </dgm:t>
@@ -7167,44 +7143,8 @@
         <a:lstStyle/>
         <a:p>
           <a:r>
-            <a:rPr lang="it-IT" err="1"/>
-            <a:t>When</a:t>
-          </a:r>
-          <a:r>
-            <a:rPr lang="it-IT"/>
-            <a:t> a </a:t>
-          </a:r>
-          <a:r>
-            <a:rPr lang="it-IT" err="1"/>
-            <a:t>change</a:t>
-          </a:r>
-          <a:r>
-            <a:rPr lang="it-IT"/>
-            <a:t> </a:t>
-          </a:r>
-          <a:r>
-            <a:rPr lang="it-IT" err="1"/>
-            <a:t>occurs</a:t>
-          </a:r>
-          <a:r>
-            <a:rPr lang="it-IT"/>
-            <a:t> on product list or </a:t>
-          </a:r>
-          <a:r>
-            <a:rPr lang="it-IT" err="1"/>
-            <a:t>remove</a:t>
-          </a:r>
-          <a:r>
-            <a:rPr lang="it-IT"/>
-            <a:t> alert state of the dispenser </a:t>
-          </a:r>
-          <a:r>
-            <a:rPr lang="it-IT" err="1"/>
-            <a:t>sends</a:t>
-          </a:r>
-          <a:r>
-            <a:rPr lang="it-IT"/>
-            <a:t> the product list</a:t>
+            <a:rPr lang="en-GB" noProof="0" dirty="0"/>
+            <a:t>When a change occurs on the product list or remove alert state of the dispenser sends the product list</a:t>
           </a:r>
         </a:p>
       </dgm:t>
@@ -7275,83 +7215,75 @@
         <a:lstStyle/>
         <a:p>
           <a:r>
-            <a:rPr lang="it-IT" err="1"/>
+            <a:rPr lang="it-IT" dirty="0" err="1"/>
             <a:t>Listens</a:t>
           </a:r>
           <a:r>
-            <a:rPr lang="it-IT"/>
+            <a:rPr lang="it-IT" dirty="0"/>
             <a:t> for HTTP </a:t>
           </a:r>
           <a:r>
-            <a:rPr lang="it-IT" err="1"/>
+            <a:rPr lang="it-IT" dirty="0" err="1"/>
             <a:t>requests</a:t>
           </a:r>
           <a:r>
-            <a:rPr lang="it-IT"/>
+            <a:rPr lang="it-IT" dirty="0"/>
             <a:t> and </a:t>
           </a:r>
           <a:r>
-            <a:rPr lang="it-IT" err="1"/>
+            <a:rPr lang="it-IT" dirty="0" err="1"/>
             <a:t>translates</a:t>
           </a:r>
           <a:r>
-            <a:rPr lang="it-IT"/>
+            <a:rPr lang="it-IT" dirty="0"/>
             <a:t> </a:t>
           </a:r>
           <a:r>
-            <a:rPr lang="it-IT" err="1"/>
+            <a:rPr lang="it-IT" dirty="0" err="1"/>
             <a:t>into</a:t>
           </a:r>
           <a:r>
-            <a:rPr lang="it-IT"/>
+            <a:rPr lang="it-IT" dirty="0"/>
             <a:t> a </a:t>
           </a:r>
           <a:r>
-            <a:rPr lang="it-IT" err="1"/>
+            <a:rPr lang="it-IT" dirty="0" err="1"/>
             <a:t>string</a:t>
           </a:r>
           <a:r>
-            <a:rPr lang="it-IT"/>
+            <a:rPr lang="it-IT" dirty="0"/>
             <a:t> to </a:t>
           </a:r>
           <a:r>
-            <a:rPr lang="it-IT" err="1"/>
+            <a:rPr lang="it-IT" dirty="0" err="1"/>
             <a:t>send</a:t>
           </a:r>
           <a:r>
-            <a:rPr lang="it-IT"/>
+            <a:rPr lang="it-IT" dirty="0"/>
             <a:t> </a:t>
           </a:r>
           <a:r>
-            <a:rPr lang="it-IT" err="1"/>
+            <a:rPr lang="it-IT" dirty="0" err="1"/>
             <a:t>through</a:t>
           </a:r>
           <a:r>
-            <a:rPr lang="it-IT"/>
+            <a:rPr lang="it-IT" dirty="0"/>
             <a:t> </a:t>
           </a:r>
           <a:r>
-            <a:rPr lang="it-IT" err="1"/>
+            <a:rPr lang="it-IT" dirty="0" err="1"/>
             <a:t>LoRa</a:t>
           </a:r>
           <a:r>
-            <a:rPr lang="it-IT"/>
-            <a:t> to </a:t>
+            <a:rPr lang="it-IT" dirty="0"/>
+            <a:t> to the </a:t>
           </a:r>
           <a:r>
-            <a:rPr lang="it-IT" err="1"/>
-            <a:t>teh</a:t>
-          </a:r>
-          <a:r>
-            <a:rPr lang="it-IT"/>
-            <a:t> </a:t>
-          </a:r>
-          <a:r>
-            <a:rPr lang="it-IT" err="1"/>
+            <a:rPr lang="it-IT" dirty="0" err="1"/>
             <a:t>correct</a:t>
           </a:r>
           <a:r>
-            <a:rPr lang="it-IT"/>
+            <a:rPr lang="it-IT" dirty="0"/>
             <a:t> dispenser</a:t>
           </a:r>
         </a:p>
@@ -7423,28 +7355,44 @@
         <a:lstStyle/>
         <a:p>
           <a:r>
-            <a:rPr lang="it-IT" err="1"/>
+            <a:rPr lang="it-IT" dirty="0" err="1"/>
             <a:t>Receives</a:t>
           </a:r>
           <a:r>
-            <a:rPr lang="it-IT"/>
+            <a:rPr lang="it-IT" dirty="0"/>
             <a:t> the </a:t>
           </a:r>
           <a:r>
-            <a:rPr lang="it-IT" err="1"/>
+            <a:rPr lang="it-IT" dirty="0" err="1"/>
             <a:t>string</a:t>
           </a:r>
           <a:r>
-            <a:rPr lang="it-IT"/>
-            <a:t> and parse the </a:t>
+            <a:rPr lang="it-IT" dirty="0"/>
+            <a:t> and </a:t>
           </a:r>
           <a:r>
-            <a:rPr lang="it-IT" err="1"/>
-            <a:t>singular</a:t>
+            <a:rPr lang="it-IT" dirty="0" err="1"/>
+            <a:t>then</a:t>
           </a:r>
           <a:r>
-            <a:rPr lang="it-IT"/>
-            <a:t> products</a:t>
+            <a:rPr lang="it-IT" dirty="0"/>
+            <a:t> </a:t>
+          </a:r>
+          <a:r>
+            <a:rPr lang="it-IT" dirty="0" err="1"/>
+            <a:t>parses</a:t>
+          </a:r>
+          <a:r>
+            <a:rPr lang="it-IT" dirty="0"/>
+            <a:t> </a:t>
+          </a:r>
+          <a:r>
+            <a:rPr lang="it-IT" dirty="0" err="1"/>
+            <a:t>each</a:t>
+          </a:r>
+          <a:r>
+            <a:rPr lang="it-IT" dirty="0"/>
+            <a:t> product</a:t>
           </a:r>
         </a:p>
       </dgm:t>
@@ -7761,52 +7709,8 @@
         <a:lstStyle/>
         <a:p>
           <a:r>
-            <a:rPr lang="it-IT" err="1"/>
-            <a:t>When</a:t>
-          </a:r>
-          <a:r>
-            <a:rPr lang="it-IT"/>
-            <a:t> </a:t>
-          </a:r>
-          <a:r>
-            <a:rPr lang="it-IT" err="1"/>
-            <a:t>there’s</a:t>
-          </a:r>
-          <a:r>
-            <a:rPr lang="it-IT"/>
-            <a:t> an item selling on the </a:t>
-          </a:r>
-          <a:r>
-            <a:rPr lang="it-IT" err="1"/>
-            <a:t>activation</a:t>
-          </a:r>
-          <a:r>
-            <a:rPr lang="it-IT"/>
-            <a:t> of the alert state, </a:t>
-          </a:r>
-          <a:r>
-            <a:rPr lang="it-IT" err="1"/>
-            <a:t>sends</a:t>
-          </a:r>
-          <a:r>
-            <a:rPr lang="it-IT"/>
-            <a:t> a </a:t>
-          </a:r>
-          <a:r>
-            <a:rPr lang="it-IT" err="1"/>
-            <a:t>LoRa</a:t>
-          </a:r>
-          <a:r>
-            <a:rPr lang="it-IT"/>
-            <a:t> to the bridge </a:t>
-          </a:r>
-          <a:r>
-            <a:rPr lang="it-IT" err="1"/>
-            <a:t>containing</a:t>
-          </a:r>
-          <a:r>
-            <a:rPr lang="it-IT"/>
-            <a:t> ID dispenser and information</a:t>
+            <a:rPr lang="en-GB" noProof="0" dirty="0"/>
+            <a:t>When an item is purchased or when the dispenser enters in an alert state, a LoRa message will be sent to the bridge containing ID dispenser and information</a:t>
           </a:r>
         </a:p>
       </dgm:t>
@@ -7841,75 +7745,83 @@
         <a:lstStyle/>
         <a:p>
           <a:r>
-            <a:rPr lang="it-IT" err="1"/>
-            <a:t>Listen</a:t>
+            <a:rPr lang="it-IT" dirty="0" err="1"/>
+            <a:t>Listens</a:t>
           </a:r>
           <a:r>
-            <a:rPr lang="it-IT"/>
+            <a:rPr lang="it-IT" dirty="0"/>
             <a:t> and </a:t>
           </a:r>
           <a:r>
-            <a:rPr lang="it-IT" err="1"/>
-            <a:t>receive</a:t>
+            <a:rPr lang="it-IT" dirty="0" err="1"/>
+            <a:t>receives</a:t>
           </a:r>
           <a:r>
-            <a:rPr lang="it-IT"/>
+            <a:rPr lang="it-IT" dirty="0"/>
             <a:t> the </a:t>
           </a:r>
           <a:r>
-            <a:rPr lang="it-IT" err="1"/>
+            <a:rPr lang="it-IT" dirty="0" err="1"/>
             <a:t>message</a:t>
           </a:r>
           <a:r>
-            <a:rPr lang="it-IT"/>
-            <a:t>, after </a:t>
+            <a:rPr lang="it-IT" dirty="0"/>
+            <a:t>; after </a:t>
           </a:r>
           <a:r>
-            <a:rPr lang="it-IT" err="1"/>
+            <a:rPr lang="it-IT" dirty="0" err="1"/>
             <a:t>parsing</a:t>
           </a:r>
           <a:r>
-            <a:rPr lang="it-IT"/>
+            <a:rPr lang="it-IT" dirty="0"/>
             <a:t> the </a:t>
           </a:r>
           <a:r>
-            <a:rPr lang="it-IT" err="1"/>
+            <a:rPr lang="it-IT" dirty="0" err="1"/>
             <a:t>message</a:t>
           </a:r>
           <a:r>
-            <a:rPr lang="it-IT"/>
+            <a:rPr lang="it-IT" dirty="0"/>
+            <a:t>, </a:t>
+          </a:r>
+          <a:r>
+            <a:rPr lang="it-IT" dirty="0" err="1"/>
+            <a:t>it</a:t>
+          </a:r>
+          <a:r>
+            <a:rPr lang="it-IT" dirty="0"/>
             <a:t> </a:t>
           </a:r>
           <a:r>
-            <a:rPr lang="it-IT" err="1"/>
-            <a:t>understand</a:t>
+            <a:rPr lang="it-IT" dirty="0" err="1"/>
+            <a:t>will</a:t>
           </a:r>
           <a:r>
-            <a:rPr lang="it-IT"/>
-            <a:t> the </a:t>
+            <a:rPr lang="it-IT" dirty="0"/>
+            <a:t> take the </a:t>
           </a:r>
           <a:r>
-            <a:rPr lang="it-IT" err="1"/>
+            <a:rPr lang="it-IT" dirty="0" err="1"/>
             <a:t>right</a:t>
           </a:r>
           <a:r>
-            <a:rPr lang="it-IT"/>
+            <a:rPr lang="it-IT" dirty="0"/>
             <a:t> action and </a:t>
           </a:r>
           <a:r>
-            <a:rPr lang="it-IT" err="1"/>
+            <a:rPr lang="it-IT" dirty="0" err="1"/>
             <a:t>notify</a:t>
           </a:r>
           <a:r>
-            <a:rPr lang="it-IT"/>
+            <a:rPr lang="it-IT" dirty="0"/>
             <a:t> the server </a:t>
           </a:r>
           <a:r>
-            <a:rPr lang="it-IT" err="1"/>
+            <a:rPr lang="it-IT" dirty="0" err="1"/>
             <a:t>through</a:t>
           </a:r>
           <a:r>
-            <a:rPr lang="it-IT"/>
+            <a:rPr lang="it-IT" dirty="0"/>
             <a:t> HTTP POST or PATCH</a:t>
           </a:r>
         </a:p>
@@ -11996,32 +11908,8 @@
             <a:buNone/>
           </a:pPr>
           <a:r>
-            <a:rPr lang="it-IT" sz="1100" kern="1200"/>
-            <a:t>To exit from the alert state, </a:t>
-          </a:r>
-          <a:r>
-            <a:rPr lang="it-IT" sz="1100" kern="1200" err="1"/>
-            <a:t>accesible</a:t>
-          </a:r>
-          <a:r>
-            <a:rPr lang="it-IT" sz="1100" kern="1200"/>
-            <a:t> </a:t>
-          </a:r>
-          <a:r>
-            <a:rPr lang="it-IT" sz="1100" kern="1200" err="1"/>
-            <a:t>only</a:t>
-          </a:r>
-          <a:r>
-            <a:rPr lang="it-IT" sz="1100" kern="1200"/>
-            <a:t> to </a:t>
-          </a:r>
-          <a:r>
-            <a:rPr lang="it-IT" sz="1100" kern="1200" err="1"/>
-            <a:t>personell</a:t>
-          </a:r>
-          <a:r>
-            <a:rPr lang="it-IT" sz="1100" kern="1200"/>
-            <a:t> </a:t>
+            <a:rPr lang="en-US" sz="1100" kern="1200" noProof="0" dirty="0"/>
+            <a:t>To exit from the alert state, accessible only to the personnel </a:t>
           </a:r>
         </a:p>
       </dsp:txBody>
@@ -13238,44 +13126,8 @@
             <a:buNone/>
           </a:pPr>
           <a:r>
-            <a:rPr lang="it-IT" sz="2000" kern="1200" err="1"/>
-            <a:t>When</a:t>
-          </a:r>
-          <a:r>
-            <a:rPr lang="it-IT" sz="2000" kern="1200"/>
-            <a:t> a </a:t>
-          </a:r>
-          <a:r>
-            <a:rPr lang="it-IT" sz="2000" kern="1200" err="1"/>
-            <a:t>change</a:t>
-          </a:r>
-          <a:r>
-            <a:rPr lang="it-IT" sz="2000" kern="1200"/>
-            <a:t> </a:t>
-          </a:r>
-          <a:r>
-            <a:rPr lang="it-IT" sz="2000" kern="1200" err="1"/>
-            <a:t>occurs</a:t>
-          </a:r>
-          <a:r>
-            <a:rPr lang="it-IT" sz="2000" kern="1200"/>
-            <a:t> on product list or </a:t>
-          </a:r>
-          <a:r>
-            <a:rPr lang="it-IT" sz="2000" kern="1200" err="1"/>
-            <a:t>remove</a:t>
-          </a:r>
-          <a:r>
-            <a:rPr lang="it-IT" sz="2000" kern="1200"/>
-            <a:t> alert state of the dispenser </a:t>
-          </a:r>
-          <a:r>
-            <a:rPr lang="it-IT" sz="2000" kern="1200" err="1"/>
-            <a:t>sends</a:t>
-          </a:r>
-          <a:r>
-            <a:rPr lang="it-IT" sz="2000" kern="1200"/>
-            <a:t> the product list</a:t>
+            <a:rPr lang="en-GB" sz="2000" kern="1200" noProof="0" dirty="0"/>
+            <a:t>When a change occurs on the product list or remove alert state of the dispenser sends the product list</a:t>
           </a:r>
         </a:p>
       </dsp:txBody>
@@ -13470,83 +13322,75 @@
             <a:buNone/>
           </a:pPr>
           <a:r>
-            <a:rPr lang="it-IT" sz="2000" kern="1200" err="1"/>
+            <a:rPr lang="it-IT" sz="2000" kern="1200" dirty="0" err="1"/>
             <a:t>Listens</a:t>
           </a:r>
           <a:r>
-            <a:rPr lang="it-IT" sz="2000" kern="1200"/>
+            <a:rPr lang="it-IT" sz="2000" kern="1200" dirty="0"/>
             <a:t> for HTTP </a:t>
           </a:r>
           <a:r>
-            <a:rPr lang="it-IT" sz="2000" kern="1200" err="1"/>
+            <a:rPr lang="it-IT" sz="2000" kern="1200" dirty="0" err="1"/>
             <a:t>requests</a:t>
           </a:r>
           <a:r>
-            <a:rPr lang="it-IT" sz="2000" kern="1200"/>
+            <a:rPr lang="it-IT" sz="2000" kern="1200" dirty="0"/>
             <a:t> and </a:t>
           </a:r>
           <a:r>
-            <a:rPr lang="it-IT" sz="2000" kern="1200" err="1"/>
+            <a:rPr lang="it-IT" sz="2000" kern="1200" dirty="0" err="1"/>
             <a:t>translates</a:t>
           </a:r>
           <a:r>
-            <a:rPr lang="it-IT" sz="2000" kern="1200"/>
+            <a:rPr lang="it-IT" sz="2000" kern="1200" dirty="0"/>
             <a:t> </a:t>
           </a:r>
           <a:r>
-            <a:rPr lang="it-IT" sz="2000" kern="1200" err="1"/>
+            <a:rPr lang="it-IT" sz="2000" kern="1200" dirty="0" err="1"/>
             <a:t>into</a:t>
           </a:r>
           <a:r>
-            <a:rPr lang="it-IT" sz="2000" kern="1200"/>
+            <a:rPr lang="it-IT" sz="2000" kern="1200" dirty="0"/>
             <a:t> a </a:t>
           </a:r>
           <a:r>
-            <a:rPr lang="it-IT" sz="2000" kern="1200" err="1"/>
+            <a:rPr lang="it-IT" sz="2000" kern="1200" dirty="0" err="1"/>
             <a:t>string</a:t>
           </a:r>
           <a:r>
-            <a:rPr lang="it-IT" sz="2000" kern="1200"/>
+            <a:rPr lang="it-IT" sz="2000" kern="1200" dirty="0"/>
             <a:t> to </a:t>
           </a:r>
           <a:r>
-            <a:rPr lang="it-IT" sz="2000" kern="1200" err="1"/>
+            <a:rPr lang="it-IT" sz="2000" kern="1200" dirty="0" err="1"/>
             <a:t>send</a:t>
           </a:r>
           <a:r>
-            <a:rPr lang="it-IT" sz="2000" kern="1200"/>
+            <a:rPr lang="it-IT" sz="2000" kern="1200" dirty="0"/>
             <a:t> </a:t>
           </a:r>
           <a:r>
-            <a:rPr lang="it-IT" sz="2000" kern="1200" err="1"/>
+            <a:rPr lang="it-IT" sz="2000" kern="1200" dirty="0" err="1"/>
             <a:t>through</a:t>
           </a:r>
           <a:r>
-            <a:rPr lang="it-IT" sz="2000" kern="1200"/>
+            <a:rPr lang="it-IT" sz="2000" kern="1200" dirty="0"/>
             <a:t> </a:t>
           </a:r>
           <a:r>
-            <a:rPr lang="it-IT" sz="2000" kern="1200" err="1"/>
+            <a:rPr lang="it-IT" sz="2000" kern="1200" dirty="0" err="1"/>
             <a:t>LoRa</a:t>
           </a:r>
           <a:r>
-            <a:rPr lang="it-IT" sz="2000" kern="1200"/>
-            <a:t> to </a:t>
+            <a:rPr lang="it-IT" sz="2000" kern="1200" dirty="0"/>
+            <a:t> to the </a:t>
           </a:r>
           <a:r>
-            <a:rPr lang="it-IT" sz="2000" kern="1200" err="1"/>
-            <a:t>teh</a:t>
-          </a:r>
-          <a:r>
-            <a:rPr lang="it-IT" sz="2000" kern="1200"/>
-            <a:t> </a:t>
-          </a:r>
-          <a:r>
-            <a:rPr lang="it-IT" sz="2000" kern="1200" err="1"/>
+            <a:rPr lang="it-IT" sz="2000" kern="1200" dirty="0" err="1"/>
             <a:t>correct</a:t>
           </a:r>
           <a:r>
-            <a:rPr lang="it-IT" sz="2000" kern="1200"/>
+            <a:rPr lang="it-IT" sz="2000" kern="1200" dirty="0"/>
             <a:t> dispenser</a:t>
           </a:r>
         </a:p>
@@ -13742,28 +13586,44 @@
             <a:buNone/>
           </a:pPr>
           <a:r>
-            <a:rPr lang="it-IT" sz="2000" kern="1200" err="1"/>
+            <a:rPr lang="it-IT" sz="2000" kern="1200" dirty="0" err="1"/>
             <a:t>Receives</a:t>
           </a:r>
           <a:r>
-            <a:rPr lang="it-IT" sz="2000" kern="1200"/>
+            <a:rPr lang="it-IT" sz="2000" kern="1200" dirty="0"/>
             <a:t> the </a:t>
           </a:r>
           <a:r>
-            <a:rPr lang="it-IT" sz="2000" kern="1200" err="1"/>
+            <a:rPr lang="it-IT" sz="2000" kern="1200" dirty="0" err="1"/>
             <a:t>string</a:t>
           </a:r>
           <a:r>
-            <a:rPr lang="it-IT" sz="2000" kern="1200"/>
-            <a:t> and parse the </a:t>
+            <a:rPr lang="it-IT" sz="2000" kern="1200" dirty="0"/>
+            <a:t> and </a:t>
           </a:r>
           <a:r>
-            <a:rPr lang="it-IT" sz="2000" kern="1200" err="1"/>
-            <a:t>singular</a:t>
+            <a:rPr lang="it-IT" sz="2000" kern="1200" dirty="0" err="1"/>
+            <a:t>then</a:t>
           </a:r>
           <a:r>
-            <a:rPr lang="it-IT" sz="2000" kern="1200"/>
-            <a:t> products</a:t>
+            <a:rPr lang="it-IT" sz="2000" kern="1200" dirty="0"/>
+            <a:t> </a:t>
+          </a:r>
+          <a:r>
+            <a:rPr lang="it-IT" sz="2000" kern="1200" dirty="0" err="1"/>
+            <a:t>parses</a:t>
+          </a:r>
+          <a:r>
+            <a:rPr lang="it-IT" sz="2000" kern="1200" dirty="0"/>
+            <a:t> </a:t>
+          </a:r>
+          <a:r>
+            <a:rPr lang="it-IT" sz="2000" kern="1200" dirty="0" err="1"/>
+            <a:t>each</a:t>
+          </a:r>
+          <a:r>
+            <a:rPr lang="it-IT" sz="2000" kern="1200" dirty="0"/>
+            <a:t> product</a:t>
           </a:r>
         </a:p>
       </dsp:txBody>
@@ -13791,7 +13651,7 @@
       </dsp:nvSpPr>
       <dsp:spPr>
         <a:xfrm>
-          <a:off x="8930" y="147259"/>
+          <a:off x="8930" y="243900"/>
           <a:ext cx="3534264" cy="1060279"/>
         </a:xfrm>
         <a:prstGeom prst="chevron">
@@ -13896,7 +13756,7 @@
         </a:p>
       </dsp:txBody>
       <dsp:txXfrm>
-        <a:off x="327014" y="147259"/>
+        <a:off x="327014" y="243900"/>
         <a:ext cx="2898096" cy="1060279"/>
       </dsp:txXfrm>
     </dsp:sp>
@@ -13907,8 +13767,8 @@
       </dsp:nvSpPr>
       <dsp:spPr>
         <a:xfrm>
-          <a:off x="8930" y="1207538"/>
-          <a:ext cx="3216180" cy="2474002"/>
+          <a:off x="8930" y="1304179"/>
+          <a:ext cx="3216180" cy="2280721"/>
         </a:xfrm>
         <a:prstGeom prst="rect">
           <a:avLst/>
@@ -13957,7 +13817,7 @@
         </a:bodyPr>
         <a:lstStyle/>
         <a:p>
-          <a:pPr marL="0" lvl="0" indent="0" algn="l" defTabSz="889000">
+          <a:pPr marL="0" lvl="0" indent="0" algn="l" defTabSz="800100">
             <a:lnSpc>
               <a:spcPct val="90000"/>
             </a:lnSpc>
@@ -13970,58 +13830,14 @@
             <a:buNone/>
           </a:pPr>
           <a:r>
-            <a:rPr lang="it-IT" sz="2000" kern="1200" err="1"/>
-            <a:t>When</a:t>
-          </a:r>
-          <a:r>
-            <a:rPr lang="it-IT" sz="2000" kern="1200"/>
-            <a:t> </a:t>
-          </a:r>
-          <a:r>
-            <a:rPr lang="it-IT" sz="2000" kern="1200" err="1"/>
-            <a:t>there’s</a:t>
-          </a:r>
-          <a:r>
-            <a:rPr lang="it-IT" sz="2000" kern="1200"/>
-            <a:t> an item selling on the </a:t>
-          </a:r>
-          <a:r>
-            <a:rPr lang="it-IT" sz="2000" kern="1200" err="1"/>
-            <a:t>activation</a:t>
-          </a:r>
-          <a:r>
-            <a:rPr lang="it-IT" sz="2000" kern="1200"/>
-            <a:t> of the alert state, </a:t>
-          </a:r>
-          <a:r>
-            <a:rPr lang="it-IT" sz="2000" kern="1200" err="1"/>
-            <a:t>sends</a:t>
-          </a:r>
-          <a:r>
-            <a:rPr lang="it-IT" sz="2000" kern="1200"/>
-            <a:t> a </a:t>
-          </a:r>
-          <a:r>
-            <a:rPr lang="it-IT" sz="2000" kern="1200" err="1"/>
-            <a:t>LoRa</a:t>
-          </a:r>
-          <a:r>
-            <a:rPr lang="it-IT" sz="2000" kern="1200"/>
-            <a:t> to the bridge </a:t>
-          </a:r>
-          <a:r>
-            <a:rPr lang="it-IT" sz="2000" kern="1200" err="1"/>
-            <a:t>containing</a:t>
-          </a:r>
-          <a:r>
-            <a:rPr lang="it-IT" sz="2000" kern="1200"/>
-            <a:t> ID dispenser and information</a:t>
+            <a:rPr lang="en-GB" sz="1800" kern="1200" noProof="0" dirty="0"/>
+            <a:t>When an item is purchased or when the dispenser enters in an alert state, a LoRa message will be sent to the bridge containing ID dispenser and information</a:t>
           </a:r>
         </a:p>
       </dsp:txBody>
       <dsp:txXfrm>
-        <a:off x="8930" y="1207538"/>
-        <a:ext cx="3216180" cy="2474002"/>
+        <a:off x="8930" y="1304179"/>
+        <a:ext cx="3216180" cy="2280721"/>
       </dsp:txXfrm>
     </dsp:sp>
     <dsp:sp modelId="{A20D5731-228C-4261-A28E-0053175647EE}">
@@ -14031,7 +13847,7 @@
       </dsp:nvSpPr>
       <dsp:spPr>
         <a:xfrm>
-          <a:off x="3490667" y="147259"/>
+          <a:off x="3490667" y="243900"/>
           <a:ext cx="3534264" cy="1060279"/>
         </a:xfrm>
         <a:prstGeom prst="chevron">
@@ -14136,7 +13952,7 @@
         </a:p>
       </dsp:txBody>
       <dsp:txXfrm>
-        <a:off x="3808751" y="147259"/>
+        <a:off x="3808751" y="243900"/>
         <a:ext cx="2898096" cy="1060279"/>
       </dsp:txXfrm>
     </dsp:sp>
@@ -14147,8 +13963,8 @@
       </dsp:nvSpPr>
       <dsp:spPr>
         <a:xfrm>
-          <a:off x="3490667" y="1207538"/>
-          <a:ext cx="3216180" cy="2474002"/>
+          <a:off x="3490667" y="1304179"/>
+          <a:ext cx="3216180" cy="2280721"/>
         </a:xfrm>
         <a:prstGeom prst="rect">
           <a:avLst/>
@@ -14197,7 +14013,7 @@
         </a:bodyPr>
         <a:lstStyle/>
         <a:p>
-          <a:pPr marL="0" lvl="0" indent="0" algn="l" defTabSz="889000">
+          <a:pPr marL="0" lvl="0" indent="0" algn="l" defTabSz="800100">
             <a:lnSpc>
               <a:spcPct val="90000"/>
             </a:lnSpc>
@@ -14210,82 +14026,90 @@
             <a:buNone/>
           </a:pPr>
           <a:r>
-            <a:rPr lang="it-IT" sz="2000" kern="1200" err="1"/>
-            <a:t>Listen</a:t>
+            <a:rPr lang="it-IT" sz="1800" kern="1200" dirty="0" err="1"/>
+            <a:t>Listens</a:t>
           </a:r>
           <a:r>
-            <a:rPr lang="it-IT" sz="2000" kern="1200"/>
+            <a:rPr lang="it-IT" sz="1800" kern="1200" dirty="0"/>
             <a:t> and </a:t>
           </a:r>
           <a:r>
-            <a:rPr lang="it-IT" sz="2000" kern="1200" err="1"/>
-            <a:t>receive</a:t>
+            <a:rPr lang="it-IT" sz="1800" kern="1200" dirty="0" err="1"/>
+            <a:t>receives</a:t>
           </a:r>
           <a:r>
-            <a:rPr lang="it-IT" sz="2000" kern="1200"/>
+            <a:rPr lang="it-IT" sz="1800" kern="1200" dirty="0"/>
             <a:t> the </a:t>
           </a:r>
           <a:r>
-            <a:rPr lang="it-IT" sz="2000" kern="1200" err="1"/>
+            <a:rPr lang="it-IT" sz="1800" kern="1200" dirty="0" err="1"/>
             <a:t>message</a:t>
           </a:r>
           <a:r>
-            <a:rPr lang="it-IT" sz="2000" kern="1200"/>
-            <a:t>, after </a:t>
+            <a:rPr lang="it-IT" sz="1800" kern="1200" dirty="0"/>
+            <a:t>; after </a:t>
           </a:r>
           <a:r>
-            <a:rPr lang="it-IT" sz="2000" kern="1200" err="1"/>
+            <a:rPr lang="it-IT" sz="1800" kern="1200" dirty="0" err="1"/>
             <a:t>parsing</a:t>
           </a:r>
           <a:r>
-            <a:rPr lang="it-IT" sz="2000" kern="1200"/>
+            <a:rPr lang="it-IT" sz="1800" kern="1200" dirty="0"/>
             <a:t> the </a:t>
           </a:r>
           <a:r>
-            <a:rPr lang="it-IT" sz="2000" kern="1200" err="1"/>
+            <a:rPr lang="it-IT" sz="1800" kern="1200" dirty="0" err="1"/>
             <a:t>message</a:t>
           </a:r>
           <a:r>
-            <a:rPr lang="it-IT" sz="2000" kern="1200"/>
+            <a:rPr lang="it-IT" sz="1800" kern="1200" dirty="0"/>
+            <a:t>, </a:t>
+          </a:r>
+          <a:r>
+            <a:rPr lang="it-IT" sz="1800" kern="1200" dirty="0" err="1"/>
+            <a:t>it</a:t>
+          </a:r>
+          <a:r>
+            <a:rPr lang="it-IT" sz="1800" kern="1200" dirty="0"/>
             <a:t> </a:t>
           </a:r>
           <a:r>
-            <a:rPr lang="it-IT" sz="2000" kern="1200" err="1"/>
-            <a:t>understand</a:t>
+            <a:rPr lang="it-IT" sz="1800" kern="1200" dirty="0" err="1"/>
+            <a:t>will</a:t>
           </a:r>
           <a:r>
-            <a:rPr lang="it-IT" sz="2000" kern="1200"/>
-            <a:t> the </a:t>
+            <a:rPr lang="it-IT" sz="1800" kern="1200" dirty="0"/>
+            <a:t> take the </a:t>
           </a:r>
           <a:r>
-            <a:rPr lang="it-IT" sz="2000" kern="1200" err="1"/>
+            <a:rPr lang="it-IT" sz="1800" kern="1200" dirty="0" err="1"/>
             <a:t>right</a:t>
           </a:r>
           <a:r>
-            <a:rPr lang="it-IT" sz="2000" kern="1200"/>
+            <a:rPr lang="it-IT" sz="1800" kern="1200" dirty="0"/>
             <a:t> action and </a:t>
           </a:r>
           <a:r>
-            <a:rPr lang="it-IT" sz="2000" kern="1200" err="1"/>
+            <a:rPr lang="it-IT" sz="1800" kern="1200" dirty="0" err="1"/>
             <a:t>notify</a:t>
           </a:r>
           <a:r>
-            <a:rPr lang="it-IT" sz="2000" kern="1200"/>
+            <a:rPr lang="it-IT" sz="1800" kern="1200" dirty="0"/>
             <a:t> the server </a:t>
           </a:r>
           <a:r>
-            <a:rPr lang="it-IT" sz="2000" kern="1200" err="1"/>
+            <a:rPr lang="it-IT" sz="1800" kern="1200" dirty="0" err="1"/>
             <a:t>through</a:t>
           </a:r>
           <a:r>
-            <a:rPr lang="it-IT" sz="2000" kern="1200"/>
+            <a:rPr lang="it-IT" sz="1800" kern="1200" dirty="0"/>
             <a:t> HTTP POST or PATCH</a:t>
           </a:r>
         </a:p>
       </dsp:txBody>
       <dsp:txXfrm>
-        <a:off x="3490667" y="1207538"/>
-        <a:ext cx="3216180" cy="2474002"/>
+        <a:off x="3490667" y="1304179"/>
+        <a:ext cx="3216180" cy="2280721"/>
       </dsp:txXfrm>
     </dsp:sp>
     <dsp:sp modelId="{50188A75-0FC4-4035-B398-F129EC7FB3AF}">
@@ -14295,7 +14119,7 @@
       </dsp:nvSpPr>
       <dsp:spPr>
         <a:xfrm>
-          <a:off x="6972405" y="147259"/>
+          <a:off x="6972405" y="243900"/>
           <a:ext cx="3534264" cy="1060279"/>
         </a:xfrm>
         <a:prstGeom prst="chevron">
@@ -14400,7 +14224,7 @@
         </a:p>
       </dsp:txBody>
       <dsp:txXfrm>
-        <a:off x="7290489" y="147259"/>
+        <a:off x="7290489" y="243900"/>
         <a:ext cx="2898096" cy="1060279"/>
       </dsp:txXfrm>
     </dsp:sp>
@@ -14411,8 +14235,8 @@
       </dsp:nvSpPr>
       <dsp:spPr>
         <a:xfrm>
-          <a:off x="6972405" y="1207538"/>
-          <a:ext cx="3216180" cy="2474002"/>
+          <a:off x="6972405" y="1304179"/>
+          <a:ext cx="3216180" cy="2280721"/>
         </a:xfrm>
         <a:prstGeom prst="rect">
           <a:avLst/>
@@ -14461,7 +14285,7 @@
         </a:bodyPr>
         <a:lstStyle/>
         <a:p>
-          <a:pPr marL="0" lvl="0" indent="0" algn="l" defTabSz="889000">
+          <a:pPr marL="0" lvl="0" indent="0" algn="l" defTabSz="800100">
             <a:lnSpc>
               <a:spcPct val="90000"/>
             </a:lnSpc>
@@ -14474,26 +14298,26 @@
             <a:buNone/>
           </a:pPr>
           <a:r>
-            <a:rPr lang="it-IT" sz="2000" kern="1200" err="1"/>
+            <a:rPr lang="it-IT" sz="1800" kern="1200" err="1"/>
             <a:t>Receives</a:t>
           </a:r>
           <a:r>
-            <a:rPr lang="it-IT" sz="2000" kern="1200"/>
+            <a:rPr lang="it-IT" sz="1800" kern="1200"/>
             <a:t> the </a:t>
           </a:r>
           <a:r>
-            <a:rPr lang="it-IT" sz="2000" kern="1200" err="1"/>
+            <a:rPr lang="it-IT" sz="1800" kern="1200" err="1"/>
             <a:t>request</a:t>
           </a:r>
           <a:r>
-            <a:rPr lang="it-IT" sz="2000" kern="1200"/>
+            <a:rPr lang="it-IT" sz="1800" kern="1200"/>
             <a:t> and updates the database</a:t>
           </a:r>
         </a:p>
       </dsp:txBody>
       <dsp:txXfrm>
-        <a:off x="6972405" y="1207538"/>
-        <a:ext cx="3216180" cy="2474002"/>
+        <a:off x="6972405" y="1304179"/>
+        <a:ext cx="3216180" cy="2280721"/>
       </dsp:txXfrm>
     </dsp:sp>
   </dsp:spTree>
@@ -29226,7 +29050,7 @@
           <a:p>
             <a:fld id="{600CED32-8595-414D-98B6-C5996E354EF9}" type="slidenum">
               <a:rPr lang="it-IT" smtClean="0"/>
-              <a:t>‹#›</a:t>
+              <a:t>‹N›</a:t>
             </a:fld>
             <a:endParaRPr lang="it-IT"/>
           </a:p>
@@ -29536,7 +29360,7 @@
           <a:p>
             <a:fld id="{7245BC23-2BDD-4F6B-B3A6-7E022BB52C35}" type="slidenum">
               <a:rPr lang="it-IT" smtClean="0"/>
-              <a:t>‹#›</a:t>
+              <a:t>‹N›</a:t>
             </a:fld>
             <a:endParaRPr lang="it-IT"/>
           </a:p>
@@ -29734,7 +29558,7 @@
           <a:p>
             <a:fld id="{7245BC23-2BDD-4F6B-B3A6-7E022BB52C35}" type="slidenum">
               <a:rPr lang="it-IT" smtClean="0"/>
-              <a:t>‹#›</a:t>
+              <a:t>‹N›</a:t>
             </a:fld>
             <a:endParaRPr lang="it-IT"/>
           </a:p>
@@ -29942,7 +29766,7 @@
           <a:p>
             <a:fld id="{7245BC23-2BDD-4F6B-B3A6-7E022BB52C35}" type="slidenum">
               <a:rPr lang="it-IT" smtClean="0"/>
-              <a:t>‹#›</a:t>
+              <a:t>‹N›</a:t>
             </a:fld>
             <a:endParaRPr lang="it-IT"/>
           </a:p>
@@ -30140,7 +29964,7 @@
           <a:p>
             <a:fld id="{7245BC23-2BDD-4F6B-B3A6-7E022BB52C35}" type="slidenum">
               <a:rPr lang="it-IT" smtClean="0"/>
-              <a:t>‹#›</a:t>
+              <a:t>‹N›</a:t>
             </a:fld>
             <a:endParaRPr lang="it-IT"/>
           </a:p>
@@ -30415,7 +30239,7 @@
           <a:p>
             <a:fld id="{7245BC23-2BDD-4F6B-B3A6-7E022BB52C35}" type="slidenum">
               <a:rPr lang="it-IT" smtClean="0"/>
-              <a:t>‹#›</a:t>
+              <a:t>‹N›</a:t>
             </a:fld>
             <a:endParaRPr lang="it-IT"/>
           </a:p>
@@ -30680,7 +30504,7 @@
           <a:p>
             <a:fld id="{7245BC23-2BDD-4F6B-B3A6-7E022BB52C35}" type="slidenum">
               <a:rPr lang="it-IT" smtClean="0"/>
-              <a:t>‹#›</a:t>
+              <a:t>‹N›</a:t>
             </a:fld>
             <a:endParaRPr lang="it-IT"/>
           </a:p>
@@ -31092,7 +30916,7 @@
           <a:p>
             <a:fld id="{7245BC23-2BDD-4F6B-B3A6-7E022BB52C35}" type="slidenum">
               <a:rPr lang="it-IT" smtClean="0"/>
-              <a:t>‹#›</a:t>
+              <a:t>‹N›</a:t>
             </a:fld>
             <a:endParaRPr lang="it-IT"/>
           </a:p>
@@ -31233,7 +31057,7 @@
           <a:p>
             <a:fld id="{7245BC23-2BDD-4F6B-B3A6-7E022BB52C35}" type="slidenum">
               <a:rPr lang="it-IT" smtClean="0"/>
-              <a:t>‹#›</a:t>
+              <a:t>‹N›</a:t>
             </a:fld>
             <a:endParaRPr lang="it-IT"/>
           </a:p>
@@ -31346,7 +31170,7 @@
           <a:p>
             <a:fld id="{7245BC23-2BDD-4F6B-B3A6-7E022BB52C35}" type="slidenum">
               <a:rPr lang="it-IT" smtClean="0"/>
-              <a:t>‹#›</a:t>
+              <a:t>‹N›</a:t>
             </a:fld>
             <a:endParaRPr lang="it-IT"/>
           </a:p>
@@ -31657,7 +31481,7 @@
           <a:p>
             <a:fld id="{7245BC23-2BDD-4F6B-B3A6-7E022BB52C35}" type="slidenum">
               <a:rPr lang="it-IT" smtClean="0"/>
-              <a:t>‹#›</a:t>
+              <a:t>‹N›</a:t>
             </a:fld>
             <a:endParaRPr lang="it-IT"/>
           </a:p>
@@ -31945,7 +31769,7 @@
           <a:p>
             <a:fld id="{7245BC23-2BDD-4F6B-B3A6-7E022BB52C35}" type="slidenum">
               <a:rPr lang="it-IT" smtClean="0"/>
-              <a:t>‹#›</a:t>
+              <a:t>‹N›</a:t>
             </a:fld>
             <a:endParaRPr lang="it-IT"/>
           </a:p>
@@ -32222,7 +32046,7 @@
           <a:p>
             <a:fld id="{7245BC23-2BDD-4F6B-B3A6-7E022BB52C35}" type="slidenum">
               <a:rPr lang="it-IT" smtClean="0"/>
-              <a:t>‹#›</a:t>
+              <a:t>‹N›</a:t>
             </a:fld>
             <a:endParaRPr lang="it-IT"/>
           </a:p>
@@ -32679,7 +32503,7 @@
           <p:nvPr>
             <p:extLst>
               <p:ext uri="{D42A27DB-BD31-4B8C-83A1-F6EECF244321}">
-                <p14:modId xmlns:p14="http://schemas.microsoft.com/office/powerpoint/2010/main" val="681025342"/>
+                <p14:modId xmlns:p14="http://schemas.microsoft.com/office/powerpoint/2010/main" val="1271739007"/>
               </p:ext>
             </p:extLst>
           </p:nvPr>
@@ -33298,7 +33122,7 @@
           <a:bodyPr/>
           <a:lstStyle/>
           <a:p>
-            <a:endParaRPr lang="en-US"/>
+            <a:endParaRPr lang="en-US" dirty="0"/>
           </a:p>
         </p:txBody>
       </p:sp>
@@ -33716,7 +33540,7 @@
             <p:ph idx="1"/>
             <p:extLst>
               <p:ext uri="{D42A27DB-BD31-4B8C-83A1-F6EECF244321}">
-                <p14:modId xmlns:p14="http://schemas.microsoft.com/office/powerpoint/2010/main" val="2685416225"/>
+                <p14:modId xmlns:p14="http://schemas.microsoft.com/office/powerpoint/2010/main" val="1706083162"/>
               </p:ext>
             </p:extLst>
           </p:nvPr>
@@ -34145,7 +33969,7 @@
             <p:ph idx="1"/>
             <p:extLst>
               <p:ext uri="{D42A27DB-BD31-4B8C-83A1-F6EECF244321}">
-                <p14:modId xmlns:p14="http://schemas.microsoft.com/office/powerpoint/2010/main" val="5936698"/>
+                <p14:modId xmlns:p14="http://schemas.microsoft.com/office/powerpoint/2010/main" val="2999626075"/>
               </p:ext>
             </p:extLst>
           </p:nvPr>
@@ -35371,7 +35195,7 @@
         <p:spPr>
           <a:xfrm>
             <a:off x="479238" y="1825061"/>
-            <a:ext cx="11231671" cy="2585323"/>
+            <a:ext cx="11231671" cy="2862322"/>
           </a:xfrm>
           <a:prstGeom prst="rect">
             <a:avLst/>
@@ -35395,7 +35219,7 @@
           <a:p>
             <a:r>
               <a:rPr lang="en-US" dirty="0"/>
-              <a:t>This way the City Council will choose more carefully what products are the most required during a certain period.</a:t>
+              <a:t>This way, the City Council will choose more carefully what products are the most required during a certain period.</a:t>
             </a:r>
           </a:p>
           <a:p>
@@ -37128,6 +36952,23 @@
 </file>
 
 <file path=customXml/item1.xml><?xml version="1.0" encoding="utf-8"?>
+<?mso-contentType ?>
+<FormTemplates xmlns="http://schemas.microsoft.com/sharepoint/v3/contenttype/forms">
+  <Display>DocumentLibraryForm</Display>
+  <Edit>DocumentLibraryForm</Edit>
+  <New>DocumentLibraryForm</New>
+</FormTemplates>
+</file>
+
+<file path=customXml/item2.xml><?xml version="1.0" encoding="utf-8"?>
+<p:properties xmlns:p="http://schemas.microsoft.com/office/2006/metadata/properties" xmlns:xsi="http://www.w3.org/2001/XMLSchema-instance" xmlns:pc="http://schemas.microsoft.com/office/infopath/2007/PartnerControls">
+  <documentManagement>
+    <_activity xmlns="16a7b784-27d1-4eb1-b12e-3f529db60055" xsi:nil="true"/>
+  </documentManagement>
+</p:properties>
+</file>
+
+<file path=customXml/item3.xml><?xml version="1.0" encoding="utf-8"?>
 <ct:contentTypeSchema xmlns:ct="http://schemas.microsoft.com/office/2006/metadata/contentType" xmlns:ma="http://schemas.microsoft.com/office/2006/metadata/properties/metaAttributes" ct:_="" ma:_="" ma:contentTypeName="Documento" ma:contentTypeID="0x01010047C00C2D6A58B54ABE327327972C15BA" ma:contentTypeVersion="15" ma:contentTypeDescription="Creare un nuovo documento." ma:contentTypeScope="" ma:versionID="a67a14e420a9cc4606c60b1997f21d8b">
   <xsd:schema xmlns:xsd="http://www.w3.org/2001/XMLSchema" xmlns:xs="http://www.w3.org/2001/XMLSchema" xmlns:p="http://schemas.microsoft.com/office/2006/metadata/properties" xmlns:ns3="16a7b784-27d1-4eb1-b12e-3f529db60055" xmlns:ns4="40838beb-f31b-4410-9b86-f6a33ae4e5ae" targetNamespace="http://schemas.microsoft.com/office/2006/metadata/properties" ma:root="true" ma:fieldsID="f21aefa642da7d8bd4ac86f34ee45476" ns3:_="" ns4:_="">
     <xsd:import namespace="16a7b784-27d1-4eb1-b12e-3f529db60055"/>
@@ -37360,38 +37201,10 @@
 </ct:contentTypeSchema>
 </file>
 
-<file path=customXml/item2.xml><?xml version="1.0" encoding="utf-8"?>
-<p:properties xmlns:p="http://schemas.microsoft.com/office/2006/metadata/properties" xmlns:xsi="http://www.w3.org/2001/XMLSchema-instance" xmlns:pc="http://schemas.microsoft.com/office/infopath/2007/PartnerControls">
-  <documentManagement>
-    <_activity xmlns="16a7b784-27d1-4eb1-b12e-3f529db60055" xsi:nil="true"/>
-  </documentManagement>
-</p:properties>
-</file>
-
-<file path=customXml/item3.xml><?xml version="1.0" encoding="utf-8"?>
-<?mso-contentType ?>
-<FormTemplates xmlns="http://schemas.microsoft.com/sharepoint/v3/contenttype/forms">
-  <Display>DocumentLibraryForm</Display>
-  <Edit>DocumentLibraryForm</Edit>
-  <New>DocumentLibraryForm</New>
-</FormTemplates>
-</file>
-
 <file path=customXml/itemProps1.xml><?xml version="1.0" encoding="utf-8"?>
-<ds:datastoreItem xmlns:ds="http://schemas.openxmlformats.org/officeDocument/2006/customXml" ds:itemID="{7D1889EF-DE48-4DF8-92A6-BD0661CF1005}">
+<ds:datastoreItem xmlns:ds="http://schemas.openxmlformats.org/officeDocument/2006/customXml" ds:itemID="{159C73F4-45FB-49BD-B927-B44F8D15CC4A}">
   <ds:schemaRefs>
-    <ds:schemaRef ds:uri="http://schemas.microsoft.com/office/2006/metadata/contentType"/>
-    <ds:schemaRef ds:uri="http://schemas.microsoft.com/office/2006/metadata/properties/metaAttributes"/>
-    <ds:schemaRef ds:uri="http://www.w3.org/2001/XMLSchema"/>
-    <ds:schemaRef ds:uri="http://schemas.microsoft.com/office/2006/metadata/properties"/>
-    <ds:schemaRef ds:uri="16a7b784-27d1-4eb1-b12e-3f529db60055"/>
-    <ds:schemaRef ds:uri="40838beb-f31b-4410-9b86-f6a33ae4e5ae"/>
-    <ds:schemaRef ds:uri="http://schemas.microsoft.com/office/2006/documentManagement/types"/>
-    <ds:schemaRef ds:uri="http://schemas.microsoft.com/office/infopath/2007/PartnerControls"/>
-    <ds:schemaRef ds:uri="http://schemas.openxmlformats.org/package/2006/metadata/core-properties"/>
-    <ds:schemaRef ds:uri="http://purl.org/dc/elements/1.1/"/>
-    <ds:schemaRef ds:uri="http://purl.org/dc/terms/"/>
-    <ds:schemaRef ds:uri="http://schemas.microsoft.com/internal/obd"/>
+    <ds:schemaRef ds:uri="http://schemas.microsoft.com/sharepoint/v3/contenttype/forms"/>
   </ds:schemaRefs>
 </ds:datastoreItem>
 </file>
@@ -37414,9 +37227,20 @@
 </file>
 
 <file path=customXml/itemProps3.xml><?xml version="1.0" encoding="utf-8"?>
-<ds:datastoreItem xmlns:ds="http://schemas.openxmlformats.org/officeDocument/2006/customXml" ds:itemID="{159C73F4-45FB-49BD-B927-B44F8D15CC4A}">
+<ds:datastoreItem xmlns:ds="http://schemas.openxmlformats.org/officeDocument/2006/customXml" ds:itemID="{7D1889EF-DE48-4DF8-92A6-BD0661CF1005}">
   <ds:schemaRefs>
-    <ds:schemaRef ds:uri="http://schemas.microsoft.com/sharepoint/v3/contenttype/forms"/>
+    <ds:schemaRef ds:uri="http://schemas.microsoft.com/office/2006/metadata/contentType"/>
+    <ds:schemaRef ds:uri="http://schemas.microsoft.com/office/2006/metadata/properties/metaAttributes"/>
+    <ds:schemaRef ds:uri="http://www.w3.org/2001/XMLSchema"/>
+    <ds:schemaRef ds:uri="http://schemas.microsoft.com/office/2006/metadata/properties"/>
+    <ds:schemaRef ds:uri="16a7b784-27d1-4eb1-b12e-3f529db60055"/>
+    <ds:schemaRef ds:uri="40838beb-f31b-4410-9b86-f6a33ae4e5ae"/>
+    <ds:schemaRef ds:uri="http://schemas.microsoft.com/office/2006/documentManagement/types"/>
+    <ds:schemaRef ds:uri="http://schemas.microsoft.com/office/infopath/2007/PartnerControls"/>
+    <ds:schemaRef ds:uri="http://schemas.openxmlformats.org/package/2006/metadata/core-properties"/>
+    <ds:schemaRef ds:uri="http://purl.org/dc/elements/1.1/"/>
+    <ds:schemaRef ds:uri="http://purl.org/dc/terms/"/>
+    <ds:schemaRef ds:uri="http://schemas.microsoft.com/internal/obd"/>
   </ds:schemaRefs>
 </ds:datastoreItem>
 </file>
</xml_diff>